<commit_message>
Expand multi-template smoke coverage and layout QA
</commit_message>
<xml_diff>
--- a/skills/uav-paper-report/assets/examples/uav-multi-quad-cbf-report.pptx
+++ b/skills/uav-paper-report/assets/examples/uav-multi-quad-cbf-report.pptx
@@ -3521,7 +3521,7 @@
               </a:spcAft>
             </a:pPr>
             <a:r>
-              <a:rPr sz="1850" b="1">
+              <a:rPr sz="1820" b="1">
                 <a:solidFill>
                   <a:srgbClr val="000000"/>
                 </a:solidFill>
@@ -3532,7 +3532,7 @@
               <a:t>● 为了避免在优化中嵌套求最小距离，论文用</a:t>
             </a:r>
             <a:r>
-              <a:rPr sz="1850" b="1">
+              <a:rPr sz="1820" b="1">
                 <a:solidFill>
                   <a:srgbClr val="DC0000"/>
                 </a:solidFill>
@@ -3543,7 +3543,7 @@
               <a:t>Duality</a:t>
             </a:r>
             <a:r>
-              <a:rPr sz="1850" b="1">
+              <a:rPr sz="1820" b="1">
                 <a:solidFill>
                   <a:srgbClr val="000000"/>
                 </a:solidFill>
@@ -3554,7 +3554,7 @@
               <a:t> theorem推导等价</a:t>
             </a:r>
             <a:r>
-              <a:rPr sz="1850" b="1">
+              <a:rPr sz="1820" b="1">
                 <a:solidFill>
                   <a:srgbClr val="DC0000"/>
                 </a:solidFill>
@@ -3565,7 +3565,7 @@
               <a:t>CBF</a:t>
             </a:r>
             <a:r>
-              <a:rPr sz="1850" b="1">
+              <a:rPr sz="1820" b="1">
                 <a:solidFill>
                   <a:srgbClr val="000000"/>
                 </a:solidFill>
@@ -4260,7 +4260,7 @@
               </a:spcAft>
             </a:pPr>
             <a:r>
-              <a:rPr sz="2080" b="0">
+              <a:rPr sz="1620" b="0">
                 <a:solidFill>
                   <a:srgbClr val="000000"/>
                 </a:solidFill>
@@ -4271,7 +4271,7 @@
               <a:t>-λ</a:t>
             </a:r>
             <a:r>
-              <a:rPr sz="1497" b="0" baseline="-25000">
+              <a:rPr sz="1620" b="0" baseline="-25000">
                 <a:solidFill>
                   <a:srgbClr val="000000"/>
                 </a:solidFill>
@@ -4282,7 +4282,7 @@
               <a:t>i</a:t>
             </a:r>
             <a:r>
-              <a:rPr sz="1497" b="0" baseline="30000">
+              <a:rPr sz="1620" b="0" baseline="30000">
                 <a:solidFill>
                   <a:srgbClr val="000000"/>
                 </a:solidFill>
@@ -4293,7 +4293,7 @@
               <a:t>obs</a:t>
             </a:r>
             <a:r>
-              <a:rPr sz="2080" b="0">
+              <a:rPr sz="1620" b="0">
                 <a:solidFill>
                   <a:srgbClr val="000000"/>
                 </a:solidFill>
@@ -4304,7 +4304,7 @@
               <a:t>B</a:t>
             </a:r>
             <a:r>
-              <a:rPr sz="1497" b="0" baseline="-25000">
+              <a:rPr sz="1620" b="0" baseline="-25000">
                 <a:solidFill>
                   <a:srgbClr val="000000"/>
                 </a:solidFill>
@@ -4315,7 +4315,7 @@
               <a:t>obs</a:t>
             </a:r>
             <a:r>
-              <a:rPr sz="2080" b="0">
+              <a:rPr sz="1620" b="0">
                 <a:solidFill>
                   <a:srgbClr val="000000"/>
                 </a:solidFill>
@@ -4326,7 +4326,7 @@
               <a:t> - λ</a:t>
             </a:r>
             <a:r>
-              <a:rPr sz="1497" b="0" baseline="-25000">
+              <a:rPr sz="1620" b="0" baseline="-25000">
                 <a:solidFill>
                   <a:srgbClr val="000000"/>
                 </a:solidFill>
@@ -4337,7 +4337,7 @@
               <a:t>i</a:t>
             </a:r>
             <a:r>
-              <a:rPr sz="1497" b="0" baseline="30000">
+              <a:rPr sz="1620" b="0" baseline="30000">
                 <a:solidFill>
                   <a:srgbClr val="000000"/>
                 </a:solidFill>
@@ -4348,7 +4348,7 @@
               <a:t>L</a:t>
             </a:r>
             <a:r>
-              <a:rPr sz="2080" b="0">
+              <a:rPr sz="1620" b="0">
                 <a:solidFill>
                   <a:srgbClr val="000000"/>
                 </a:solidFill>
@@ -4359,7 +4359,7 @@
               <a:t>B</a:t>
             </a:r>
             <a:r>
-              <a:rPr sz="1497" b="0" baseline="-25000">
+              <a:rPr sz="1620" b="0" baseline="-25000">
                 <a:solidFill>
                   <a:srgbClr val="000000"/>
                 </a:solidFill>
@@ -4370,7 +4370,7 @@
               <a:t>L</a:t>
             </a:r>
             <a:r>
-              <a:rPr sz="2080" b="0">
+              <a:rPr sz="1620" b="0">
                 <a:solidFill>
                   <a:srgbClr val="000000"/>
                 </a:solidFill>
@@ -4381,7 +4381,7 @@
               <a:t>(X</a:t>
             </a:r>
             <a:r>
-              <a:rPr sz="1497" b="0" baseline="-25000">
+              <a:rPr sz="1620" b="0" baseline="-25000">
                 <a:solidFill>
                   <a:srgbClr val="000000"/>
                 </a:solidFill>
@@ -4392,7 +4392,7 @@
               <a:t>i+1</a:t>
             </a:r>
             <a:r>
-              <a:rPr sz="2080" b="0">
+              <a:rPr sz="1620" b="0">
                 <a:solidFill>
                   <a:srgbClr val="000000"/>
                 </a:solidFill>
@@ -4403,7 +4403,7 @@
               <a:t>) ≥ γ</a:t>
             </a:r>
             <a:r>
-              <a:rPr sz="1497" b="0" baseline="-25000">
+              <a:rPr sz="1620" b="0" baseline="-25000">
                 <a:solidFill>
                   <a:srgbClr val="000000"/>
                 </a:solidFill>
@@ -4414,7 +4414,7 @@
               <a:t>i</a:t>
             </a:r>
             <a:r>
-              <a:rPr sz="2080" b="0">
+              <a:rPr sz="1620" b="0">
                 <a:solidFill>
                   <a:srgbClr val="000000"/>
                 </a:solidFill>
@@ -4425,7 +4425,7 @@
               <a:t>h(X</a:t>
             </a:r>
             <a:r>
-              <a:rPr sz="1497" b="0" baseline="-25000">
+              <a:rPr sz="1620" b="0" baseline="-25000">
                 <a:solidFill>
                   <a:srgbClr val="000000"/>
                 </a:solidFill>
@@ -4436,7 +4436,7 @@
               <a:t>i</a:t>
             </a:r>
             <a:r>
-              <a:rPr sz="2080" b="0">
+              <a:rPr sz="1620" b="0">
                 <a:solidFill>
                   <a:srgbClr val="000000"/>
                 </a:solidFill>
@@ -5144,7 +5144,7 @@
               </a:spcAft>
             </a:pPr>
             <a:r>
-              <a:rPr sz="1810" b="1">
+              <a:rPr sz="1820" b="1">
                 <a:solidFill>
                   <a:srgbClr val="000000"/>
                 </a:solidFill>
@@ -5155,7 +5155,7 @@
               <a:t>● 指数</a:t>
             </a:r>
             <a:r>
-              <a:rPr sz="1810" b="1">
+              <a:rPr sz="1820" b="1">
                 <a:solidFill>
                   <a:srgbClr val="DC0000"/>
                 </a:solidFill>
@@ -5166,7 +5166,7 @@
               <a:t>CBF</a:t>
             </a:r>
             <a:r>
-              <a:rPr sz="1810" b="1">
+              <a:rPr sz="1820" b="1">
                 <a:solidFill>
                   <a:srgbClr val="000000"/>
                 </a:solidFill>
@@ -5190,7 +5190,7 @@
               </a:spcAft>
             </a:pPr>
             <a:r>
-              <a:rPr sz="1710" b="0">
+              <a:rPr sz="1680" b="0">
                 <a:solidFill>
                   <a:srgbClr val="000000"/>
                 </a:solidFill>
@@ -5313,7 +5313,7 @@
               </a:spcAft>
             </a:pPr>
             <a:r>
-              <a:rPr sz="2200" b="0">
+              <a:rPr sz="1620" b="0">
                 <a:solidFill>
                   <a:srgbClr val="000000"/>
                 </a:solidFill>
@@ -5324,7 +5324,7 @@
               <a:t>-λ</a:t>
             </a:r>
             <a:r>
-              <a:rPr sz="1584" b="0" baseline="-25000">
+              <a:rPr sz="1620" b="0" baseline="-25000">
                 <a:solidFill>
                   <a:srgbClr val="000000"/>
                 </a:solidFill>
@@ -5335,7 +5335,7 @@
               <a:t>i</a:t>
             </a:r>
             <a:r>
-              <a:rPr sz="1584" b="0" baseline="30000">
+              <a:rPr sz="1620" b="0" baseline="30000">
                 <a:solidFill>
                   <a:srgbClr val="000000"/>
                 </a:solidFill>
@@ -5346,7 +5346,7 @@
               <a:t>obs</a:t>
             </a:r>
             <a:r>
-              <a:rPr sz="2200" b="0">
+              <a:rPr sz="1620" b="0">
                 <a:solidFill>
                   <a:srgbClr val="000000"/>
                 </a:solidFill>
@@ -5357,7 +5357,7 @@
               <a:t>B</a:t>
             </a:r>
             <a:r>
-              <a:rPr sz="1584" b="0" baseline="-25000">
+              <a:rPr sz="1620" b="0" baseline="-25000">
                 <a:solidFill>
                   <a:srgbClr val="000000"/>
                 </a:solidFill>
@@ -5368,7 +5368,7 @@
               <a:t>obs</a:t>
             </a:r>
             <a:r>
-              <a:rPr sz="2200" b="0">
+              <a:rPr sz="1620" b="0">
                 <a:solidFill>
                   <a:srgbClr val="000000"/>
                 </a:solidFill>
@@ -5379,7 +5379,7 @@
               <a:t> - λ</a:t>
             </a:r>
             <a:r>
-              <a:rPr sz="1584" b="0" baseline="-25000">
+              <a:rPr sz="1620" b="0" baseline="-25000">
                 <a:solidFill>
                   <a:srgbClr val="000000"/>
                 </a:solidFill>
@@ -5390,7 +5390,7 @@
               <a:t>i</a:t>
             </a:r>
             <a:r>
-              <a:rPr sz="1584" b="0" baseline="30000">
+              <a:rPr sz="1620" b="0" baseline="30000">
                 <a:solidFill>
                   <a:srgbClr val="000000"/>
                 </a:solidFill>
@@ -5401,7 +5401,7 @@
               <a:t>L</a:t>
             </a:r>
             <a:r>
-              <a:rPr sz="2200" b="0">
+              <a:rPr sz="1620" b="0">
                 <a:solidFill>
                   <a:srgbClr val="000000"/>
                 </a:solidFill>
@@ -5412,7 +5412,7 @@
               <a:t>B</a:t>
             </a:r>
             <a:r>
-              <a:rPr sz="1584" b="0" baseline="-25000">
+              <a:rPr sz="1620" b="0" baseline="-25000">
                 <a:solidFill>
                   <a:srgbClr val="000000"/>
                 </a:solidFill>
@@ -5423,7 +5423,7 @@
               <a:t>L</a:t>
             </a:r>
             <a:r>
-              <a:rPr sz="2200" b="0">
+              <a:rPr sz="1620" b="0">
                 <a:solidFill>
                   <a:srgbClr val="000000"/>
                 </a:solidFill>
@@ -5434,7 +5434,7 @@
               <a:t>(X</a:t>
             </a:r>
             <a:r>
-              <a:rPr sz="1584" b="0" baseline="-25000">
+              <a:rPr sz="1620" b="0" baseline="-25000">
                 <a:solidFill>
                   <a:srgbClr val="000000"/>
                 </a:solidFill>
@@ -5445,7 +5445,7 @@
               <a:t>i+1</a:t>
             </a:r>
             <a:r>
-              <a:rPr sz="2200" b="0">
+              <a:rPr sz="1620" b="0">
                 <a:solidFill>
                   <a:srgbClr val="000000"/>
                 </a:solidFill>
@@ -5456,7 +5456,7 @@
               <a:t>) ≥ α</a:t>
             </a:r>
             <a:r>
-              <a:rPr sz="1584" b="0" baseline="-25000">
+              <a:rPr sz="1620" b="0" baseline="-25000">
                 <a:solidFill>
                   <a:srgbClr val="000000"/>
                 </a:solidFill>
@@ -5467,7 +5467,7 @@
               <a:t>i</a:t>
             </a:r>
             <a:r>
-              <a:rPr sz="2200" b="0">
+              <a:rPr sz="1620" b="0">
                 <a:solidFill>
                   <a:srgbClr val="000000"/>
                 </a:solidFill>
@@ -5478,7 +5478,7 @@
               <a:t> Π</a:t>
             </a:r>
             <a:r>
-              <a:rPr sz="1584" b="0" baseline="-25000">
+              <a:rPr sz="1620" b="0" baseline="-25000">
                 <a:solidFill>
                   <a:srgbClr val="000000"/>
                 </a:solidFill>
@@ -5489,7 +5489,7 @@
               <a:t>j=0</a:t>
             </a:r>
             <a:r>
-              <a:rPr sz="1584" b="0" baseline="30000">
+              <a:rPr sz="1620" b="0" baseline="30000">
                 <a:solidFill>
                   <a:srgbClr val="000000"/>
                 </a:solidFill>
@@ -5500,7 +5500,7 @@
               <a:t>i</a:t>
             </a:r>
             <a:r>
-              <a:rPr sz="2200" b="0">
+              <a:rPr sz="1620" b="0">
                 <a:solidFill>
                   <a:srgbClr val="000000"/>
                 </a:solidFill>
@@ -5511,7 +5511,7 @@
               <a:t>γ</a:t>
             </a:r>
             <a:r>
-              <a:rPr sz="1584" b="0" baseline="-25000">
+              <a:rPr sz="1620" b="0" baseline="-25000">
                 <a:solidFill>
                   <a:srgbClr val="000000"/>
                 </a:solidFill>
@@ -5522,7 +5522,7 @@
               <a:t>j</a:t>
             </a:r>
             <a:r>
-              <a:rPr sz="2200" b="0">
+              <a:rPr sz="1620" b="0">
                 <a:solidFill>
                   <a:srgbClr val="000000"/>
                 </a:solidFill>
@@ -5533,7 +5533,7 @@
               <a:t>h(X</a:t>
             </a:r>
             <a:r>
-              <a:rPr sz="1584" b="0" baseline="-25000">
+              <a:rPr sz="1620" b="0" baseline="-25000">
                 <a:solidFill>
                   <a:srgbClr val="000000"/>
                 </a:solidFill>
@@ -5544,7 +5544,7 @@
               <a:t>0</a:t>
             </a:r>
             <a:r>
-              <a:rPr sz="2200" b="0">
+              <a:rPr sz="1620" b="0">
                 <a:solidFill>
                   <a:srgbClr val="000000"/>
                 </a:solidFill>
@@ -6385,7 +6385,7 @@
               </a:spcAft>
             </a:pPr>
             <a:r>
-              <a:rPr sz="1850" b="1">
+              <a:rPr sz="1820" b="1">
                 <a:solidFill>
                   <a:srgbClr val="000000"/>
                 </a:solidFill>
@@ -6396,7 +6396,7 @@
               <a:t>● 在线阶段以当前状态为初值，反复求解带</a:t>
             </a:r>
             <a:r>
-              <a:rPr sz="1850" b="1">
+              <a:rPr sz="1820" b="1">
                 <a:solidFill>
                   <a:srgbClr val="DC0000"/>
                 </a:solidFill>
@@ -6407,7 +6407,7 @@
               <a:t>CBF</a:t>
             </a:r>
             <a:r>
-              <a:rPr sz="1850" b="1">
+              <a:rPr sz="1820" b="1">
                 <a:solidFill>
                   <a:srgbClr val="000000"/>
                 </a:solidFill>
@@ -7695,7 +7695,7 @@
               </a:spcAft>
             </a:pPr>
             <a:r>
-              <a:rPr sz="1780" b="1">
+              <a:rPr sz="1820" b="1">
                 <a:solidFill>
                   <a:srgbClr val="000000"/>
                 </a:solidFill>
@@ -7706,7 +7706,7 @@
               <a:t>● 实验采用RotorTM仿真和三机</a:t>
             </a:r>
             <a:r>
-              <a:rPr sz="1780" b="1">
+              <a:rPr sz="1820" b="1">
                 <a:solidFill>
                   <a:srgbClr val="DC0000"/>
                 </a:solidFill>
@@ -7717,7 +7717,7 @@
               <a:t>实机</a:t>
             </a:r>
             <a:r>
-              <a:rPr sz="1780" b="1">
+              <a:rPr sz="1820" b="1">
                 <a:solidFill>
                   <a:srgbClr val="000000"/>
                 </a:solidFill>
@@ -8478,15 +8478,15 @@
               </a:spcAft>
             </a:pPr>
             <a:r>
-              <a:rPr sz="1830" b="1">
-                <a:solidFill>
-                  <a:srgbClr val="000000"/>
-                </a:solidFill>
-                <a:latin typeface="Times New Roman"/>
-                <a:ea typeface="Times New Roman"/>
-                <a:cs typeface="Times New Roman"/>
-              </a:rPr>
-              <a:t>● 仿真环境包含多种窄通道、扭曲通道和随机障碍，用于测试规划器的局部几何适应能力。</a:t>
+              <a:rPr sz="1820" b="1">
+                <a:solidFill>
+                  <a:srgbClr val="000000"/>
+                </a:solidFill>
+                <a:latin typeface="Times New Roman"/>
+                <a:ea typeface="Times New Roman"/>
+                <a:cs typeface="Times New Roman"/>
+              </a:rPr>
+              <a:t>● 仿真环境包含多种窄通道、扭曲通道和随机障碍，评估规划器对局部几何变化的适应能力。</a:t>
             </a:r>
           </a:p>
         </p:txBody>
@@ -8549,7 +8549,7 @@
               </a:spcAft>
             </a:pPr>
             <a:r>
-              <a:rPr sz="1780" b="1">
+              <a:rPr sz="1820" b="1">
                 <a:solidFill>
                   <a:srgbClr val="000000"/>
                 </a:solidFill>
@@ -9627,7 +9627,7 @@
               </a:spcAft>
             </a:pPr>
             <a:r>
-              <a:rPr sz="1780" b="1">
+              <a:rPr sz="1820" b="1">
                 <a:solidFill>
                   <a:srgbClr val="000000"/>
                 </a:solidFill>
@@ -9638,7 +9638,7 @@
               <a:t>● 没有</a:t>
             </a:r>
             <a:r>
-              <a:rPr sz="1780" b="1">
+              <a:rPr sz="1820" b="1">
                 <a:solidFill>
                   <a:srgbClr val="DC0000"/>
                 </a:solidFill>
@@ -9649,7 +9649,7 @@
               <a:t>全局参考</a:t>
             </a:r>
             <a:r>
-              <a:rPr sz="1780" b="1">
+              <a:rPr sz="1820" b="1">
                 <a:solidFill>
                   <a:srgbClr val="000000"/>
                 </a:solidFill>
@@ -10498,7 +10498,7 @@
               </a:spcAft>
             </a:pPr>
             <a:r>
-              <a:rPr sz="1839" b="1">
+              <a:rPr sz="1820" b="1">
                 <a:solidFill>
                   <a:srgbClr val="000000"/>
                 </a:solidFill>
@@ -10509,7 +10509,7 @@
               <a:t>● </a:t>
             </a:r>
             <a:r>
-              <a:rPr sz="1839" b="1">
+              <a:rPr sz="1820" b="1">
                 <a:solidFill>
                   <a:srgbClr val="DC0000"/>
                 </a:solidFill>
@@ -10520,7 +10520,7 @@
               <a:t>实机</a:t>
             </a:r>
             <a:r>
-              <a:rPr sz="1839" b="1">
+              <a:rPr sz="1820" b="1">
                 <a:solidFill>
                   <a:srgbClr val="000000"/>
                 </a:solidFill>
@@ -10956,7 +10956,7 @@
               </a:spcAft>
             </a:pPr>
             <a:r>
-              <a:rPr sz="1780" b="1">
+              <a:rPr sz="1820" b="1">
                 <a:solidFill>
                   <a:srgbClr val="000000"/>
                 </a:solidFill>
@@ -10967,7 +10967,7 @@
               <a:t>● 仿真验证</a:t>
             </a:r>
             <a:r>
-              <a:rPr sz="1780" b="1">
+              <a:rPr sz="1820" b="1">
                 <a:solidFill>
                   <a:srgbClr val="DC0000"/>
                 </a:solidFill>
@@ -10978,7 +10978,7 @@
               <a:t>全局参考</a:t>
             </a:r>
             <a:r>
-              <a:rPr sz="1780" b="1">
+              <a:rPr sz="1820" b="1">
                 <a:solidFill>
                   <a:srgbClr val="000000"/>
                 </a:solidFill>
@@ -10989,7 +10989,7 @@
               <a:t> + </a:t>
             </a:r>
             <a:r>
-              <a:rPr sz="1780" b="1">
+              <a:rPr sz="1820" b="1">
                 <a:solidFill>
                   <a:srgbClr val="DC0000"/>
                 </a:solidFill>
@@ -11000,7 +11000,7 @@
               <a:t>CBF</a:t>
             </a:r>
             <a:r>
-              <a:rPr sz="1780" b="1">
+              <a:rPr sz="1820" b="1">
                 <a:solidFill>
                   <a:srgbClr val="000000"/>
                 </a:solidFill>
@@ -11011,7 +11011,7 @@
               <a:t>-</a:t>
             </a:r>
             <a:r>
-              <a:rPr sz="1780" b="1">
+              <a:rPr sz="1820" b="1">
                 <a:solidFill>
                   <a:srgbClr val="DC0000"/>
                 </a:solidFill>
@@ -11022,7 +11022,7 @@
               <a:t>MPC</a:t>
             </a:r>
             <a:r>
-              <a:rPr sz="1780" b="1">
+              <a:rPr sz="1820" b="1">
                 <a:solidFill>
                   <a:srgbClr val="000000"/>
                 </a:solidFill>
@@ -11183,7 +11183,7 @@
               </a:spcAft>
             </a:pPr>
             <a:r>
-              <a:rPr sz="1780" b="1">
+              <a:rPr sz="1820" b="1">
                 <a:solidFill>
                   <a:srgbClr val="000000"/>
                 </a:solidFill>
@@ -11194,7 +11194,7 @@
               <a:t>● </a:t>
             </a:r>
             <a:r>
-              <a:rPr sz="1780" b="1">
+              <a:rPr sz="1820" b="1">
                 <a:solidFill>
                   <a:srgbClr val="DC0000"/>
                 </a:solidFill>
@@ -11205,7 +11205,7 @@
               <a:t>实机</a:t>
             </a:r>
             <a:r>
-              <a:rPr sz="1780" b="1">
+              <a:rPr sz="1820" b="1">
                 <a:solidFill>
                   <a:srgbClr val="000000"/>
                 </a:solidFill>
@@ -11989,7 +11989,7 @@
               </a:spcAft>
             </a:pPr>
             <a:r>
-              <a:rPr sz="1880" b="1">
+              <a:rPr sz="1820" b="1">
                 <a:solidFill>
                   <a:srgbClr val="000000"/>
                 </a:solidFill>
@@ -12924,7 +12924,7 @@
               </a:spcAft>
             </a:pPr>
             <a:r>
-              <a:rPr sz="1830" b="1">
+              <a:rPr sz="1820" b="1">
                 <a:solidFill>
                   <a:srgbClr val="000000"/>
                 </a:solidFill>
@@ -12948,7 +12948,7 @@
               </a:spcAft>
             </a:pPr>
             <a:r>
-              <a:rPr sz="1730" b="0">
+              <a:rPr sz="1680" b="0">
                 <a:solidFill>
                   <a:srgbClr val="000000"/>
                 </a:solidFill>
@@ -13602,7 +13602,7 @@
               </a:spcAft>
             </a:pPr>
             <a:r>
-              <a:rPr sz="1810" b="1">
+              <a:rPr sz="1820" b="1">
                 <a:solidFill>
                   <a:srgbClr val="000000"/>
                 </a:solidFill>
@@ -13626,7 +13626,7 @@
               </a:spcAft>
             </a:pPr>
             <a:r>
-              <a:rPr sz="1710" b="0">
+              <a:rPr sz="1680" b="0">
                 <a:solidFill>
                   <a:srgbClr val="000000"/>
                 </a:solidFill>
@@ -13637,7 +13637,7 @@
               <a:t>• 系统包含四旋翼、缆绳和</a:t>
             </a:r>
             <a:r>
-              <a:rPr sz="1710" b="1">
+              <a:rPr sz="1680" b="1">
                 <a:solidFill>
                   <a:srgbClr val="DC0000"/>
                 </a:solidFill>
@@ -13648,7 +13648,7 @@
               <a:t>六自由度</a:t>
             </a:r>
             <a:r>
-              <a:rPr sz="1710" b="0">
+              <a:rPr sz="1680" b="0">
                 <a:solidFill>
                   <a:srgbClr val="000000"/>
                 </a:solidFill>
@@ -13672,7 +13672,7 @@
               </a:spcAft>
             </a:pPr>
             <a:r>
-              <a:rPr sz="1710" b="0">
+              <a:rPr sz="1680" b="0">
                 <a:solidFill>
                   <a:srgbClr val="000000"/>
                 </a:solidFill>
@@ -13696,7 +13696,7 @@
               </a:spcAft>
             </a:pPr>
             <a:r>
-              <a:rPr sz="1710" b="0">
+              <a:rPr sz="1680" b="0">
                 <a:solidFill>
                   <a:srgbClr val="000000"/>
                 </a:solidFill>
@@ -14865,7 +14865,7 @@
               </a:spcAft>
             </a:pPr>
             <a:r>
-              <a:rPr sz="1800" b="1">
+              <a:rPr sz="1820" b="1">
                 <a:solidFill>
                   <a:srgbClr val="000000"/>
                 </a:solidFill>
@@ -14876,7 +14876,7 @@
               <a:t>● 本文把协同搬运系统的几何外形和动力学耦合写入</a:t>
             </a:r>
             <a:r>
-              <a:rPr sz="1800" b="1">
+              <a:rPr sz="1820" b="1">
                 <a:solidFill>
                   <a:srgbClr val="DC0000"/>
                 </a:solidFill>
@@ -14887,7 +14887,7 @@
               <a:t>CBF</a:t>
             </a:r>
             <a:r>
-              <a:rPr sz="1800" b="1">
+              <a:rPr sz="1820" b="1">
                 <a:solidFill>
                   <a:srgbClr val="000000"/>
                 </a:solidFill>
@@ -14898,7 +14898,7 @@
               <a:t>-</a:t>
             </a:r>
             <a:r>
-              <a:rPr sz="1800" b="1">
+              <a:rPr sz="1820" b="1">
                 <a:solidFill>
                   <a:srgbClr val="DC0000"/>
                 </a:solidFill>
@@ -14909,7 +14909,7 @@
               <a:t>MPC</a:t>
             </a:r>
             <a:r>
-              <a:rPr sz="1800" b="1">
+              <a:rPr sz="1820" b="1">
                 <a:solidFill>
                   <a:srgbClr val="000000"/>
                 </a:solidFill>
@@ -14933,7 +14933,7 @@
               </a:spcAft>
             </a:pPr>
             <a:r>
-              <a:rPr sz="1700" b="0">
+              <a:rPr sz="1680" b="0">
                 <a:solidFill>
                   <a:srgbClr val="000000"/>
                 </a:solidFill>
@@ -15941,7 +15941,7 @@
               </a:spcAft>
             </a:pPr>
             <a:r>
-              <a:rPr sz="1720" b="0">
+              <a:rPr sz="1680" b="0">
                 <a:solidFill>
                   <a:srgbClr val="000000"/>
                 </a:solidFill>
@@ -15952,7 +15952,7 @@
               <a:t>• </a:t>
             </a:r>
             <a:r>
-              <a:rPr sz="1720" b="1">
+              <a:rPr sz="1680" b="1">
                 <a:solidFill>
                   <a:srgbClr val="DC0000"/>
                 </a:solidFill>
@@ -15963,7 +15963,7 @@
               <a:t>CBF</a:t>
             </a:r>
             <a:r>
-              <a:rPr sz="1720" b="0">
+              <a:rPr sz="1680" b="0">
                 <a:solidFill>
                   <a:srgbClr val="000000"/>
                 </a:solidFill>
@@ -15987,7 +15987,7 @@
               </a:spcAft>
             </a:pPr>
             <a:r>
-              <a:rPr sz="1720" b="0">
+              <a:rPr sz="1680" b="0">
                 <a:solidFill>
                   <a:srgbClr val="000000"/>
                 </a:solidFill>
@@ -15998,7 +15998,7 @@
               <a:t>• A* </a:t>
             </a:r>
             <a:r>
-              <a:rPr sz="1720" b="1">
+              <a:rPr sz="1680" b="1">
                 <a:solidFill>
                   <a:srgbClr val="DC0000"/>
                 </a:solidFill>
@@ -16009,7 +16009,7 @@
               <a:t>全局参考</a:t>
             </a:r>
             <a:r>
-              <a:rPr sz="1720" b="0">
+              <a:rPr sz="1680" b="0">
                 <a:solidFill>
                   <a:srgbClr val="000000"/>
                 </a:solidFill>
@@ -16618,7 +16618,7 @@
               </a:spcAft>
             </a:pPr>
             <a:r>
-              <a:rPr sz="1880" b="1">
+              <a:rPr sz="1820" b="1">
                 <a:solidFill>
                   <a:srgbClr val="000000"/>
                 </a:solidFill>
@@ -17473,7 +17473,7 @@
               </a:spcAft>
             </a:pPr>
             <a:r>
-              <a:rPr sz="1780" b="1">
+              <a:rPr sz="1820" b="1">
                 <a:solidFill>
                   <a:srgbClr val="000000"/>
                 </a:solidFill>
@@ -18557,7 +18557,7 @@
               </a:spcAft>
             </a:pPr>
             <a:r>
-              <a:rPr sz="1860" b="1">
+              <a:rPr sz="1820" b="1">
                 <a:solidFill>
                   <a:srgbClr val="000000"/>
                 </a:solidFill>
@@ -20159,7 +20159,7 @@
               </a:spcAft>
             </a:pPr>
             <a:r>
-              <a:rPr sz="1780" b="1">
+              <a:rPr sz="1820" b="1">
                 <a:solidFill>
                   <a:srgbClr val="000000"/>
                 </a:solidFill>
@@ -20170,7 +20170,7 @@
               <a:t>● 论文用</a:t>
             </a:r>
             <a:r>
-              <a:rPr sz="1780" b="1">
+              <a:rPr sz="1820" b="1">
                 <a:solidFill>
                   <a:srgbClr val="DC0000"/>
                 </a:solidFill>
@@ -20181,7 +20181,7 @@
               <a:t>convex polytopes</a:t>
             </a:r>
             <a:r>
-              <a:rPr sz="1780" b="1">
+              <a:rPr sz="1820" b="1">
                 <a:solidFill>
                   <a:srgbClr val="000000"/>
                 </a:solidFill>
@@ -20983,7 +20983,7 @@
               </a:spcAft>
             </a:pPr>
             <a:r>
-              <a:rPr sz="1860" b="1">
+              <a:rPr sz="1820" b="1">
                 <a:solidFill>
                   <a:srgbClr val="000000"/>
                 </a:solidFill>
@@ -22660,7 +22660,7 @@
               </a:spcAft>
             </a:pPr>
             <a:r>
-              <a:rPr sz="1830" b="1">
+              <a:rPr sz="1820" b="1">
                 <a:solidFill>
                   <a:srgbClr val="000000"/>
                 </a:solidFill>
@@ -22671,7 +22671,7 @@
               <a:t>● </a:t>
             </a:r>
             <a:r>
-              <a:rPr sz="1830" b="1">
+              <a:rPr sz="1820" b="1">
                 <a:solidFill>
                   <a:srgbClr val="DC0000"/>
                 </a:solidFill>
@@ -22682,7 +22682,7 @@
               <a:t>CBF</a:t>
             </a:r>
             <a:r>
-              <a:rPr sz="1830" b="1">
+              <a:rPr sz="1820" b="1">
                 <a:solidFill>
                   <a:srgbClr val="000000"/>
                 </a:solidFill>
@@ -22706,7 +22706,7 @@
               </a:spcAft>
             </a:pPr>
             <a:r>
-              <a:rPr sz="1730" b="0">
+              <a:rPr sz="1680" b="0">
                 <a:solidFill>
                   <a:srgbClr val="000000"/>
                 </a:solidFill>
@@ -23382,7 +23382,7 @@
               </a:spcAft>
             </a:pPr>
             <a:r>
-              <a:rPr sz="1600" b="0">
+              <a:rPr sz="1680" b="0">
                 <a:solidFill>
                   <a:srgbClr val="000000"/>
                 </a:solidFill>
@@ -23406,7 +23406,7 @@
               </a:spcAft>
             </a:pPr>
             <a:r>
-              <a:rPr sz="1600" b="0">
+              <a:rPr sz="1680" b="0">
                 <a:solidFill>
                   <a:srgbClr val="000000"/>
                 </a:solidFill>
@@ -23430,7 +23430,7 @@
               </a:spcAft>
             </a:pPr>
             <a:r>
-              <a:rPr sz="1600" b="0">
+              <a:rPr sz="1680" b="0">
                 <a:solidFill>
                   <a:srgbClr val="000000"/>
                 </a:solidFill>

</xml_diff>